<commit_message>
Add real AMD Developer Cloud inference: runner script, captured kits, updated deck with real output
</commit_message>
<xml_diff>
--- a/AI_Launchpad_Deck.pptx
+++ b/AI_Launchpad_Deck.pptx
@@ -3147,8 +3147,8 @@
         </p:nvSpPr>
         <p:spPr>
           <a:xfrm>
-            <a:off x="4221327" y="1234440"/>
-            <a:ext cx="3749039" cy="384048"/>
+            <a:off x="4129887" y="1234440"/>
+            <a:ext cx="3931920" cy="384048"/>
           </a:xfrm>
           <a:prstGeom prst="roundRect">
             <a:avLst>
@@ -3191,7 +3191,7 @@
                 </a:solidFill>
                 <a:latin typeface="Calibri"/>
               </a:rPr>
-              <a:t>●  Powered by AMD GPUs · Fireworks AI</a:t>
+              <a:t>●  Powered by AMD Developer Cloud GPUs</a:t>
             </a:r>
           </a:p>
         </p:txBody>
@@ -5924,7 +5924,7 @@
                 </a:solidFill>
                 <a:latin typeface="Calibri"/>
               </a:rPr>
-              <a:t>Fireworks AI, running on AMD GPUs</a:t>
+              <a:t>an open model running on AMD GPUs (vLLM)</a:t>
             </a:r>
             <a:r>
               <a:rPr sz="1550" b="0" i="0">
@@ -6026,7 +6026,7 @@
         </p:nvSpPr>
         <p:spPr>
           <a:xfrm>
-            <a:off x="822960" y="640080"/>
+            <a:off x="822960" y="566928"/>
             <a:ext cx="10515600" cy="731520"/>
           </a:xfrm>
           <a:prstGeom prst="rect">
@@ -6048,7 +6048,7 @@
                 </a:solidFill>
                 <a:latin typeface="Calibri"/>
               </a:rPr>
-              <a:t>Watch a brand appear live</a:t>
+              <a:t>Real output, generated on AMD</a:t>
             </a:r>
           </a:p>
         </p:txBody>
@@ -6061,8 +6061,8 @@
         </p:nvSpPr>
         <p:spPr>
           <a:xfrm>
-            <a:off x="822960" y="1417320"/>
-            <a:ext cx="10515600" cy="548640"/>
+            <a:off x="822960" y="1325880"/>
+            <a:ext cx="10515600" cy="502920"/>
           </a:xfrm>
           <a:prstGeom prst="rect">
             <a:avLst/>
@@ -6075,15 +6075,37 @@
           </a:bodyPr>
           <a:lstStyle/>
           <a:p>
-            <a:pPr algn="l"/>
-            <a:r>
-              <a:rPr sz="1700" b="0" i="0">
+            <a:pPr algn="l">
+              <a:lnSpc>
+                <a:spcPct val="105000"/>
+              </a:lnSpc>
+            </a:pPr>
+            <a:r>
+              <a:rPr sz="1600" b="0" i="0">
                 <a:solidFill>
                   <a:srgbClr val="94A3B8"/>
                 </a:solidFill>
                 <a:latin typeface="Calibri"/>
               </a:rPr>
-              <a:t>The four agents light up one by one — then the full startup kit reveals, section by section.</a:t>
+              <a:t>From </a:t>
+            </a:r>
+            <a:r>
+              <a:rPr sz="1600" b="1" i="0">
+                <a:solidFill>
+                  <a:srgbClr val="F8FAFC"/>
+                </a:solidFill>
+                <a:latin typeface="Calibri"/>
+              </a:rPr>
+              <a:t>“an app that helps students find part-time jobs”</a:t>
+            </a:r>
+            <a:r>
+              <a:rPr sz="1600" b="0" i="0">
+                <a:solidFill>
+                  <a:srgbClr val="94A3B8"/>
+                </a:solidFill>
+                <a:latin typeface="Calibri"/>
+              </a:rPr>
+              <a:t> — one real run of the crew on an AMD GPU.</a:t>
             </a:r>
           </a:p>
         </p:txBody>
@@ -6096,12 +6118,12 @@
         </p:nvSpPr>
         <p:spPr>
           <a:xfrm>
-            <a:off x="2194560" y="2286000"/>
-            <a:ext cx="7772400" cy="3794760"/>
+            <a:off x="822960" y="1965960"/>
+            <a:ext cx="6766560" cy="3977639"/>
           </a:xfrm>
           <a:prstGeom prst="roundRect">
             <a:avLst>
-              <a:gd name="adj" fmla="val 5000"/>
+              <a:gd name="adj" fmla="val 4000"/>
             </a:avLst>
           </a:prstGeom>
           <a:solidFill>
@@ -6145,14 +6167,104 @@
       </p:sp>
       <p:sp>
         <p:nvSpPr>
-          <p:cNvPr id="6" name="TextBox 5"/>
+          <p:cNvPr id="6" name="Rounded Rectangle 5"/>
+          <p:cNvSpPr/>
+          <p:nvPr/>
+        </p:nvSpPr>
+        <p:spPr>
+          <a:xfrm>
+            <a:off x="1143000" y="2286000"/>
+            <a:ext cx="658368" cy="658368"/>
+          </a:xfrm>
+          <a:prstGeom prst="roundRect">
+            <a:avLst>
+              <a:gd name="adj" fmla="val 25000"/>
+            </a:avLst>
+          </a:prstGeom>
+          <a:solidFill>
+            <a:srgbClr val="2563EB"/>
+          </a:solidFill>
+          <a:ln>
+            <a:noFill/>
+          </a:ln>
+          <a:effectLst/>
+        </p:spPr>
+        <p:style>
+          <a:lnRef idx="1">
+            <a:schemeClr val="accent1"/>
+          </a:lnRef>
+          <a:fillRef idx="3">
+            <a:schemeClr val="accent1"/>
+          </a:fillRef>
+          <a:effectRef idx="2">
+            <a:schemeClr val="accent1"/>
+          </a:effectRef>
+          <a:fontRef idx="minor">
+            <a:schemeClr val="lt1"/>
+          </a:fontRef>
+        </p:style>
+        <p:txBody>
+          <a:bodyPr rtlCol="0" anchor="ctr" wrap="square" lIns="45720" rIns="45720" tIns="0" bIns="0"/>
+          <a:lstStyle/>
+          <a:p>
+            <a:pPr algn="ctr"/>
+            <a:r>
+              <a:rPr sz="2600" b="1">
+                <a:solidFill>
+                  <a:srgbClr val="F8FAFC"/>
+                </a:solidFill>
+                <a:latin typeface="Calibri"/>
+              </a:rPr>
+              <a:t>J</a:t>
+            </a:r>
+          </a:p>
+        </p:txBody>
+      </p:sp>
+      <p:sp>
+        <p:nvSpPr>
+          <p:cNvPr id="7" name="TextBox 6"/>
           <p:cNvSpPr txBox="1"/>
           <p:nvPr/>
         </p:nvSpPr>
         <p:spPr>
           <a:xfrm>
-            <a:off x="2194560" y="3703320"/>
-            <a:ext cx="7772400" cy="548640"/>
+            <a:off x="1938528" y="2286000"/>
+            <a:ext cx="4754880" cy="457200"/>
+          </a:xfrm>
+          <a:prstGeom prst="rect">
+            <a:avLst/>
+          </a:prstGeom>
+          <a:noFill/>
+        </p:spPr>
+        <p:txBody>
+          <a:bodyPr wrap="square" anchor="ctr" lIns="0" rIns="0" tIns="0" bIns="0">
+            <a:spAutoFit/>
+          </a:bodyPr>
+          <a:lstStyle/>
+          <a:p>
+            <a:pPr algn="l"/>
+            <a:r>
+              <a:rPr sz="2300" b="1" i="0">
+                <a:solidFill>
+                  <a:srgbClr val="F8FAFC"/>
+                </a:solidFill>
+                <a:latin typeface="Calibri"/>
+              </a:rPr>
+              <a:t>JobHopper</a:t>
+            </a:r>
+          </a:p>
+        </p:txBody>
+      </p:sp>
+      <p:sp>
+        <p:nvSpPr>
+          <p:cNvPr id="8" name="TextBox 7"/>
+          <p:cNvSpPr txBox="1"/>
+          <p:nvPr/>
+        </p:nvSpPr>
+        <p:spPr>
+          <a:xfrm>
+            <a:off x="1956816" y="2779776"/>
+            <a:ext cx="5120640" cy="320040"/>
           </a:xfrm>
           <a:prstGeom prst="rect">
             <a:avLst/>
@@ -6165,29 +6277,29 @@
           </a:bodyPr>
           <a:lstStyle/>
           <a:p>
-            <a:pPr algn="ctr"/>
-            <a:r>
-              <a:rPr sz="2200" b="1" i="0">
-                <a:solidFill>
-                  <a:srgbClr val="94A3B8"/>
-                </a:solidFill>
-                <a:latin typeface="Calibri"/>
-              </a:rPr>
-              <a:t>App demo screenshot</a:t>
-            </a:r>
-          </a:p>
-        </p:txBody>
-      </p:sp>
-      <p:sp>
-        <p:nvSpPr>
-          <p:cNvPr id="7" name="TextBox 6"/>
+            <a:pPr algn="l"/>
+            <a:r>
+              <a:rPr sz="1250" b="0" i="1">
+                <a:solidFill>
+                  <a:srgbClr val="38BDF8"/>
+                </a:solidFill>
+                <a:latin typeface="Calibri"/>
+              </a:rPr>
+              <a:t>Find your flex job, college student!</a:t>
+            </a:r>
+          </a:p>
+        </p:txBody>
+      </p:sp>
+      <p:sp>
+        <p:nvSpPr>
+          <p:cNvPr id="9" name="TextBox 8"/>
           <p:cNvSpPr txBox="1"/>
           <p:nvPr/>
         </p:nvSpPr>
         <p:spPr>
           <a:xfrm>
-            <a:off x="2194560" y="4343400"/>
-            <a:ext cx="7772400" cy="457200"/>
+            <a:off x="1143000" y="3310128"/>
+            <a:ext cx="6263640" cy="640080"/>
           </a:xfrm>
           <a:prstGeom prst="rect">
             <a:avLst/>
@@ -6200,15 +6312,789 @@
           </a:bodyPr>
           <a:lstStyle/>
           <a:p>
+            <a:pPr algn="l">
+              <a:lnSpc>
+                <a:spcPct val="102000"/>
+              </a:lnSpc>
+            </a:pPr>
+            <a:r>
+              <a:rPr sz="1800" b="1" i="0">
+                <a:solidFill>
+                  <a:srgbClr val="F8FAFC"/>
+                </a:solidFill>
+                <a:latin typeface="Calibri"/>
+              </a:rPr>
+              <a:t>Find Your Dream Job, Tailored Just For You</a:t>
+            </a:r>
+          </a:p>
+        </p:txBody>
+      </p:sp>
+      <p:sp>
+        <p:nvSpPr>
+          <p:cNvPr id="10" name="TextBox 9"/>
+          <p:cNvSpPr txBox="1"/>
+          <p:nvPr/>
+        </p:nvSpPr>
+        <p:spPr>
+          <a:xfrm>
+            <a:off x="1143000" y="4041648"/>
+            <a:ext cx="6263640" cy="685800"/>
+          </a:xfrm>
+          <a:prstGeom prst="rect">
+            <a:avLst/>
+          </a:prstGeom>
+          <a:noFill/>
+        </p:spPr>
+        <p:txBody>
+          <a:bodyPr wrap="square" anchor="t" lIns="0" rIns="0" tIns="0" bIns="0">
+            <a:spAutoFit/>
+          </a:bodyPr>
+          <a:lstStyle/>
+          <a:p>
+            <a:pPr algn="l">
+              <a:lnSpc>
+                <a:spcPct val="105000"/>
+              </a:lnSpc>
+            </a:pPr>
+            <a:r>
+              <a:rPr sz="1200" b="0" i="0">
+                <a:solidFill>
+                  <a:srgbClr val="94A3B8"/>
+                </a:solidFill>
+                <a:latin typeface="Calibri"/>
+              </a:rPr>
+              <a:t>JobHopper connects you with customized job opportunities that fit your skills and preferences. Work on your terms.</a:t>
+            </a:r>
+          </a:p>
+        </p:txBody>
+      </p:sp>
+      <p:sp>
+        <p:nvSpPr>
+          <p:cNvPr id="11" name="Rounded Rectangle 10"/>
+          <p:cNvSpPr/>
+          <p:nvPr/>
+        </p:nvSpPr>
+        <p:spPr>
+          <a:xfrm>
+            <a:off x="1143000" y="4828032"/>
+            <a:ext cx="1993392" cy="457200"/>
+          </a:xfrm>
+          <a:prstGeom prst="roundRect">
+            <a:avLst>
+              <a:gd name="adj" fmla="val 50000"/>
+            </a:avLst>
+          </a:prstGeom>
+          <a:solidFill>
+            <a:srgbClr val="243147"/>
+          </a:solidFill>
+          <a:ln w="9525">
+            <a:solidFill>
+              <a:srgbClr val="334155"/>
+            </a:solidFill>
+          </a:ln>
+          <a:effectLst/>
+        </p:spPr>
+        <p:style>
+          <a:lnRef idx="1">
+            <a:schemeClr val="accent1"/>
+          </a:lnRef>
+          <a:fillRef idx="3">
+            <a:schemeClr val="accent1"/>
+          </a:fillRef>
+          <a:effectRef idx="2">
+            <a:schemeClr val="accent1"/>
+          </a:effectRef>
+          <a:fontRef idx="minor">
+            <a:schemeClr val="lt1"/>
+          </a:fontRef>
+        </p:style>
+        <p:txBody>
+          <a:bodyPr rtlCol="0" anchor="ctr" wrap="square" lIns="45720" rIns="45720" tIns="0" bIns="0"/>
+          <a:lstStyle/>
+          <a:p>
             <a:pPr algn="ctr"/>
             <a:r>
-              <a:rPr sz="1300" b="0" i="1">
+              <a:rPr sz="1050" b="1">
+                <a:solidFill>
+                  <a:srgbClr val="F8FAFC"/>
+                </a:solidFill>
+                <a:latin typeface="Calibri"/>
+              </a:rPr>
+              <a:t>Tailored Opportunities</a:t>
+            </a:r>
+          </a:p>
+        </p:txBody>
+      </p:sp>
+      <p:sp>
+        <p:nvSpPr>
+          <p:cNvPr id="12" name="Rounded Rectangle 11"/>
+          <p:cNvSpPr/>
+          <p:nvPr/>
+        </p:nvSpPr>
+        <p:spPr>
+          <a:xfrm>
+            <a:off x="3273552" y="4828032"/>
+            <a:ext cx="1993392" cy="457200"/>
+          </a:xfrm>
+          <a:prstGeom prst="roundRect">
+            <a:avLst>
+              <a:gd name="adj" fmla="val 50000"/>
+            </a:avLst>
+          </a:prstGeom>
+          <a:solidFill>
+            <a:srgbClr val="243147"/>
+          </a:solidFill>
+          <a:ln w="9525">
+            <a:solidFill>
+              <a:srgbClr val="334155"/>
+            </a:solidFill>
+          </a:ln>
+          <a:effectLst/>
+        </p:spPr>
+        <p:style>
+          <a:lnRef idx="1">
+            <a:schemeClr val="accent1"/>
+          </a:lnRef>
+          <a:fillRef idx="3">
+            <a:schemeClr val="accent1"/>
+          </a:fillRef>
+          <a:effectRef idx="2">
+            <a:schemeClr val="accent1"/>
+          </a:effectRef>
+          <a:fontRef idx="minor">
+            <a:schemeClr val="lt1"/>
+          </a:fontRef>
+        </p:style>
+        <p:txBody>
+          <a:bodyPr rtlCol="0" anchor="ctr" wrap="square" lIns="45720" rIns="45720" tIns="0" bIns="0"/>
+          <a:lstStyle/>
+          <a:p>
+            <a:pPr algn="ctr"/>
+            <a:r>
+              <a:rPr sz="1050" b="1">
+                <a:solidFill>
+                  <a:srgbClr val="F8FAFC"/>
+                </a:solidFill>
+                <a:latin typeface="Calibri"/>
+              </a:rPr>
+              <a:t>Flexible Hours</a:t>
+            </a:r>
+          </a:p>
+        </p:txBody>
+      </p:sp>
+      <p:sp>
+        <p:nvSpPr>
+          <p:cNvPr id="13" name="Rounded Rectangle 12"/>
+          <p:cNvSpPr/>
+          <p:nvPr/>
+        </p:nvSpPr>
+        <p:spPr>
+          <a:xfrm>
+            <a:off x="5404104" y="4828032"/>
+            <a:ext cx="1993392" cy="457200"/>
+          </a:xfrm>
+          <a:prstGeom prst="roundRect">
+            <a:avLst>
+              <a:gd name="adj" fmla="val 50000"/>
+            </a:avLst>
+          </a:prstGeom>
+          <a:solidFill>
+            <a:srgbClr val="243147"/>
+          </a:solidFill>
+          <a:ln w="9525">
+            <a:solidFill>
+              <a:srgbClr val="334155"/>
+            </a:solidFill>
+          </a:ln>
+          <a:effectLst/>
+        </p:spPr>
+        <p:style>
+          <a:lnRef idx="1">
+            <a:schemeClr val="accent1"/>
+          </a:lnRef>
+          <a:fillRef idx="3">
+            <a:schemeClr val="accent1"/>
+          </a:fillRef>
+          <a:effectRef idx="2">
+            <a:schemeClr val="accent1"/>
+          </a:effectRef>
+          <a:fontRef idx="minor">
+            <a:schemeClr val="lt1"/>
+          </a:fontRef>
+        </p:style>
+        <p:txBody>
+          <a:bodyPr rtlCol="0" anchor="ctr" wrap="square" lIns="45720" rIns="45720" tIns="0" bIns="0"/>
+          <a:lstStyle/>
+          <a:p>
+            <a:pPr algn="ctr"/>
+            <a:r>
+              <a:rPr sz="1050" b="1">
+                <a:solidFill>
+                  <a:srgbClr val="F8FAFC"/>
+                </a:solidFill>
+                <a:latin typeface="Calibri"/>
+              </a:rPr>
+              <a:t>Personalized Recs</a:t>
+            </a:r>
+          </a:p>
+        </p:txBody>
+      </p:sp>
+      <p:sp>
+        <p:nvSpPr>
+          <p:cNvPr id="14" name="Rounded Rectangle 13"/>
+          <p:cNvSpPr/>
+          <p:nvPr/>
+        </p:nvSpPr>
+        <p:spPr>
+          <a:xfrm>
+            <a:off x="1143000" y="5440680"/>
+            <a:ext cx="3886200" cy="457200"/>
+          </a:xfrm>
+          <a:prstGeom prst="roundRect">
+            <a:avLst>
+              <a:gd name="adj" fmla="val 50000"/>
+            </a:avLst>
+          </a:prstGeom>
+          <a:solidFill>
+            <a:srgbClr val="2563EB"/>
+          </a:solidFill>
+          <a:ln>
+            <a:noFill/>
+          </a:ln>
+          <a:effectLst/>
+        </p:spPr>
+        <p:style>
+          <a:lnRef idx="1">
+            <a:schemeClr val="accent1"/>
+          </a:lnRef>
+          <a:fillRef idx="3">
+            <a:schemeClr val="accent1"/>
+          </a:fillRef>
+          <a:effectRef idx="2">
+            <a:schemeClr val="accent1"/>
+          </a:effectRef>
+          <a:fontRef idx="minor">
+            <a:schemeClr val="lt1"/>
+          </a:fontRef>
+        </p:style>
+        <p:txBody>
+          <a:bodyPr rtlCol="0" anchor="ctr" wrap="square" lIns="45720" rIns="45720" tIns="0" bIns="0"/>
+          <a:lstStyle/>
+          <a:p>
+            <a:pPr algn="ctr"/>
+            <a:r>
+              <a:rPr sz="1200" b="1">
+                <a:solidFill>
+                  <a:srgbClr val="F8FAFC"/>
+                </a:solidFill>
+                <a:latin typeface="Calibri"/>
+              </a:rPr>
+              <a:t>Start Your JobHopper Journey Now  →</a:t>
+            </a:r>
+          </a:p>
+        </p:txBody>
+      </p:sp>
+      <p:sp>
+        <p:nvSpPr>
+          <p:cNvPr id="15" name="Rounded Rectangle 14"/>
+          <p:cNvSpPr/>
+          <p:nvPr/>
+        </p:nvSpPr>
+        <p:spPr>
+          <a:xfrm>
+            <a:off x="7818120" y="1965960"/>
+            <a:ext cx="3547872" cy="3977639"/>
+          </a:xfrm>
+          <a:prstGeom prst="roundRect">
+            <a:avLst>
+              <a:gd name="adj" fmla="val 9000"/>
+            </a:avLst>
+          </a:prstGeom>
+          <a:solidFill>
+            <a:srgbClr val="243147"/>
+          </a:solidFill>
+          <a:ln w="9525">
+            <a:solidFill>
+              <a:srgbClr val="334155"/>
+            </a:solidFill>
+          </a:ln>
+          <a:effectLst/>
+          <a:effectLst>
+            <a:outerShdw blurRad="90000" dist="40000" dir="5400000" rotWithShape="0">
+              <a:srgbClr val="000000">
+                <a:alpha val="32000"/>
+              </a:srgbClr>
+            </a:outerShdw>
+          </a:effectLst>
+        </p:spPr>
+        <p:style>
+          <a:lnRef idx="1">
+            <a:schemeClr val="accent1"/>
+          </a:lnRef>
+          <a:fillRef idx="3">
+            <a:schemeClr val="accent1"/>
+          </a:fillRef>
+          <a:effectRef idx="2">
+            <a:schemeClr val="accent1"/>
+          </a:effectRef>
+          <a:fontRef idx="minor">
+            <a:schemeClr val="lt1"/>
+          </a:fontRef>
+        </p:style>
+        <p:txBody>
+          <a:bodyPr rtlCol="0" anchor="ctr"/>
+          <a:lstStyle/>
+          <a:p>
+            <a:pPr algn="ctr"/>
+          </a:p>
+        </p:txBody>
+      </p:sp>
+      <p:sp>
+        <p:nvSpPr>
+          <p:cNvPr id="16" name="TextBox 15"/>
+          <p:cNvSpPr txBox="1"/>
+          <p:nvPr/>
+        </p:nvSpPr>
+        <p:spPr>
+          <a:xfrm>
+            <a:off x="8138160" y="2212848"/>
+            <a:ext cx="3017520" cy="320040"/>
+          </a:xfrm>
+          <a:prstGeom prst="rect">
+            <a:avLst/>
+          </a:prstGeom>
+          <a:noFill/>
+        </p:spPr>
+        <p:txBody>
+          <a:bodyPr wrap="square" anchor="t" lIns="0" rIns="0" tIns="0" bIns="0">
+            <a:spAutoFit/>
+          </a:bodyPr>
+          <a:lstStyle/>
+          <a:p>
+            <a:pPr algn="l"/>
+            <a:r>
+              <a:rPr sz="1100" b="1" i="0">
+                <a:solidFill>
+                  <a:srgbClr val="38BDF8"/>
+                </a:solidFill>
+                <a:latin typeface="Calibri"/>
+              </a:rPr>
+              <a:t>BRAND PALETTE</a:t>
+            </a:r>
+          </a:p>
+        </p:txBody>
+      </p:sp>
+      <p:sp>
+        <p:nvSpPr>
+          <p:cNvPr id="17" name="Rounded Rectangle 16"/>
+          <p:cNvSpPr/>
+          <p:nvPr/>
+        </p:nvSpPr>
+        <p:spPr>
+          <a:xfrm>
+            <a:off x="8138160" y="2560320"/>
+            <a:ext cx="457200" cy="457200"/>
+          </a:xfrm>
+          <a:prstGeom prst="roundRect">
+            <a:avLst>
+              <a:gd name="adj" fmla="val 18000"/>
+            </a:avLst>
+          </a:prstGeom>
+          <a:solidFill>
+            <a:srgbClr val="4CAF50"/>
+          </a:solidFill>
+          <a:ln w="6350">
+            <a:solidFill>
+              <a:srgbClr val="334155"/>
+            </a:solidFill>
+          </a:ln>
+          <a:effectLst/>
+        </p:spPr>
+        <p:style>
+          <a:lnRef idx="1">
+            <a:schemeClr val="accent1"/>
+          </a:lnRef>
+          <a:fillRef idx="3">
+            <a:schemeClr val="accent1"/>
+          </a:fillRef>
+          <a:effectRef idx="2">
+            <a:schemeClr val="accent1"/>
+          </a:effectRef>
+          <a:fontRef idx="minor">
+            <a:schemeClr val="lt1"/>
+          </a:fontRef>
+        </p:style>
+        <p:txBody>
+          <a:bodyPr rtlCol="0" anchor="ctr"/>
+          <a:lstStyle/>
+          <a:p>
+            <a:pPr algn="ctr"/>
+          </a:p>
+        </p:txBody>
+      </p:sp>
+      <p:sp>
+        <p:nvSpPr>
+          <p:cNvPr id="18" name="Rounded Rectangle 17"/>
+          <p:cNvSpPr/>
+          <p:nvPr/>
+        </p:nvSpPr>
+        <p:spPr>
+          <a:xfrm>
+            <a:off x="8668512" y="2560320"/>
+            <a:ext cx="457200" cy="457200"/>
+          </a:xfrm>
+          <a:prstGeom prst="roundRect">
+            <a:avLst>
+              <a:gd name="adj" fmla="val 18000"/>
+            </a:avLst>
+          </a:prstGeom>
+          <a:solidFill>
+            <a:srgbClr val="2E8B57"/>
+          </a:solidFill>
+          <a:ln w="6350">
+            <a:solidFill>
+              <a:srgbClr val="334155"/>
+            </a:solidFill>
+          </a:ln>
+          <a:effectLst/>
+        </p:spPr>
+        <p:style>
+          <a:lnRef idx="1">
+            <a:schemeClr val="accent1"/>
+          </a:lnRef>
+          <a:fillRef idx="3">
+            <a:schemeClr val="accent1"/>
+          </a:fillRef>
+          <a:effectRef idx="2">
+            <a:schemeClr val="accent1"/>
+          </a:effectRef>
+          <a:fontRef idx="minor">
+            <a:schemeClr val="lt1"/>
+          </a:fontRef>
+        </p:style>
+        <p:txBody>
+          <a:bodyPr rtlCol="0" anchor="ctr"/>
+          <a:lstStyle/>
+          <a:p>
+            <a:pPr algn="ctr"/>
+          </a:p>
+        </p:txBody>
+      </p:sp>
+      <p:sp>
+        <p:nvSpPr>
+          <p:cNvPr id="19" name="Rounded Rectangle 18"/>
+          <p:cNvSpPr/>
+          <p:nvPr/>
+        </p:nvSpPr>
+        <p:spPr>
+          <a:xfrm>
+            <a:off x="9198864" y="2560320"/>
+            <a:ext cx="457200" cy="457200"/>
+          </a:xfrm>
+          <a:prstGeom prst="roundRect">
+            <a:avLst>
+              <a:gd name="adj" fmla="val 18000"/>
+            </a:avLst>
+          </a:prstGeom>
+          <a:solidFill>
+            <a:srgbClr val="32CD32"/>
+          </a:solidFill>
+          <a:ln w="6350">
+            <a:solidFill>
+              <a:srgbClr val="334155"/>
+            </a:solidFill>
+          </a:ln>
+          <a:effectLst/>
+        </p:spPr>
+        <p:style>
+          <a:lnRef idx="1">
+            <a:schemeClr val="accent1"/>
+          </a:lnRef>
+          <a:fillRef idx="3">
+            <a:schemeClr val="accent1"/>
+          </a:fillRef>
+          <a:effectRef idx="2">
+            <a:schemeClr val="accent1"/>
+          </a:effectRef>
+          <a:fontRef idx="minor">
+            <a:schemeClr val="lt1"/>
+          </a:fontRef>
+        </p:style>
+        <p:txBody>
+          <a:bodyPr rtlCol="0" anchor="ctr"/>
+          <a:lstStyle/>
+          <a:p>
+            <a:pPr algn="ctr"/>
+          </a:p>
+        </p:txBody>
+      </p:sp>
+      <p:sp>
+        <p:nvSpPr>
+          <p:cNvPr id="20" name="Rounded Rectangle 19"/>
+          <p:cNvSpPr/>
+          <p:nvPr/>
+        </p:nvSpPr>
+        <p:spPr>
+          <a:xfrm>
+            <a:off x="9729216" y="2560320"/>
+            <a:ext cx="457200" cy="457200"/>
+          </a:xfrm>
+          <a:prstGeom prst="roundRect">
+            <a:avLst>
+              <a:gd name="adj" fmla="val 18000"/>
+            </a:avLst>
+          </a:prstGeom>
+          <a:solidFill>
+            <a:srgbClr val="98FB98"/>
+          </a:solidFill>
+          <a:ln w="6350">
+            <a:solidFill>
+              <a:srgbClr val="334155"/>
+            </a:solidFill>
+          </a:ln>
+          <a:effectLst/>
+        </p:spPr>
+        <p:style>
+          <a:lnRef idx="1">
+            <a:schemeClr val="accent1"/>
+          </a:lnRef>
+          <a:fillRef idx="3">
+            <a:schemeClr val="accent1"/>
+          </a:fillRef>
+          <a:effectRef idx="2">
+            <a:schemeClr val="accent1"/>
+          </a:effectRef>
+          <a:fontRef idx="minor">
+            <a:schemeClr val="lt1"/>
+          </a:fontRef>
+        </p:style>
+        <p:txBody>
+          <a:bodyPr rtlCol="0" anchor="ctr"/>
+          <a:lstStyle/>
+          <a:p>
+            <a:pPr algn="ctr"/>
+          </a:p>
+        </p:txBody>
+      </p:sp>
+      <p:sp>
+        <p:nvSpPr>
+          <p:cNvPr id="21" name="Rounded Rectangle 20"/>
+          <p:cNvSpPr/>
+          <p:nvPr/>
+        </p:nvSpPr>
+        <p:spPr>
+          <a:xfrm>
+            <a:off x="10259568" y="2560320"/>
+            <a:ext cx="457200" cy="457200"/>
+          </a:xfrm>
+          <a:prstGeom prst="roundRect">
+            <a:avLst>
+              <a:gd name="adj" fmla="val 18000"/>
+            </a:avLst>
+          </a:prstGeom>
+          <a:solidFill>
+            <a:srgbClr val="D3D3D3"/>
+          </a:solidFill>
+          <a:ln w="6350">
+            <a:solidFill>
+              <a:srgbClr val="334155"/>
+            </a:solidFill>
+          </a:ln>
+          <a:effectLst/>
+        </p:spPr>
+        <p:style>
+          <a:lnRef idx="1">
+            <a:schemeClr val="accent1"/>
+          </a:lnRef>
+          <a:fillRef idx="3">
+            <a:schemeClr val="accent1"/>
+          </a:fillRef>
+          <a:effectRef idx="2">
+            <a:schemeClr val="accent1"/>
+          </a:effectRef>
+          <a:fontRef idx="minor">
+            <a:schemeClr val="lt1"/>
+          </a:fontRef>
+        </p:style>
+        <p:txBody>
+          <a:bodyPr rtlCol="0" anchor="ctr"/>
+          <a:lstStyle/>
+          <a:p>
+            <a:pPr algn="ctr"/>
+          </a:p>
+        </p:txBody>
+      </p:sp>
+      <p:sp>
+        <p:nvSpPr>
+          <p:cNvPr id="22" name="TextBox 21"/>
+          <p:cNvSpPr txBox="1"/>
+          <p:nvPr/>
+        </p:nvSpPr>
+        <p:spPr>
+          <a:xfrm>
+            <a:off x="8138160" y="3246120"/>
+            <a:ext cx="3017520" cy="320040"/>
+          </a:xfrm>
+          <a:prstGeom prst="rect">
+            <a:avLst/>
+          </a:prstGeom>
+          <a:noFill/>
+        </p:spPr>
+        <p:txBody>
+          <a:bodyPr wrap="square" anchor="t" lIns="0" rIns="0" tIns="0" bIns="0">
+            <a:spAutoFit/>
+          </a:bodyPr>
+          <a:lstStyle/>
+          <a:p>
+            <a:pPr algn="l"/>
+            <a:r>
+              <a:rPr sz="1100" b="1" i="0">
+                <a:solidFill>
+                  <a:srgbClr val="38BDF8"/>
+                </a:solidFill>
+                <a:latin typeface="Calibri"/>
+              </a:rPr>
+              <a:t>LAUNCH POST</a:t>
+            </a:r>
+          </a:p>
+        </p:txBody>
+      </p:sp>
+      <p:sp>
+        <p:nvSpPr>
+          <p:cNvPr id="23" name="TextBox 22"/>
+          <p:cNvSpPr txBox="1"/>
+          <p:nvPr/>
+        </p:nvSpPr>
+        <p:spPr>
+          <a:xfrm>
+            <a:off x="8138160" y="3566160"/>
+            <a:ext cx="3017520" cy="1371600"/>
+          </a:xfrm>
+          <a:prstGeom prst="rect">
+            <a:avLst/>
+          </a:prstGeom>
+          <a:noFill/>
+        </p:spPr>
+        <p:txBody>
+          <a:bodyPr wrap="square" anchor="t" lIns="0" rIns="0" tIns="0" bIns="0">
+            <a:spAutoFit/>
+          </a:bodyPr>
+          <a:lstStyle/>
+          <a:p>
+            <a:pPr algn="l">
+              <a:lnSpc>
+                <a:spcPct val="108000"/>
+              </a:lnSpc>
+            </a:pPr>
+            <a:r>
+              <a:rPr sz="1100" b="0" i="1">
+                <a:solidFill>
+                  <a:srgbClr val="F8FAFC"/>
+                </a:solidFill>
+                <a:latin typeface="Calibri"/>
+              </a:rPr>
+              <a:t>“Revolutionize your job search with JobHopper! Find tailored opportunities &amp; work on your terms. #JobHopper #CareerRevolution”</a:t>
+            </a:r>
+          </a:p>
+        </p:txBody>
+      </p:sp>
+      <p:sp>
+        <p:nvSpPr>
+          <p:cNvPr id="24" name="Rounded Rectangle 23"/>
+          <p:cNvSpPr/>
+          <p:nvPr/>
+        </p:nvSpPr>
+        <p:spPr>
+          <a:xfrm>
+            <a:off x="8138160" y="5349240"/>
+            <a:ext cx="2907792" cy="457200"/>
+          </a:xfrm>
+          <a:prstGeom prst="roundRect">
+            <a:avLst>
+              <a:gd name="adj" fmla="val 50000"/>
+            </a:avLst>
+          </a:prstGeom>
+          <a:solidFill>
+            <a:srgbClr val="0F172A"/>
+          </a:solidFill>
+          <a:ln w="9525">
+            <a:solidFill>
+              <a:srgbClr val="334155"/>
+            </a:solidFill>
+          </a:ln>
+          <a:effectLst/>
+        </p:spPr>
+        <p:style>
+          <a:lnRef idx="1">
+            <a:schemeClr val="accent1"/>
+          </a:lnRef>
+          <a:fillRef idx="3">
+            <a:schemeClr val="accent1"/>
+          </a:fillRef>
+          <a:effectRef idx="2">
+            <a:schemeClr val="accent1"/>
+          </a:effectRef>
+          <a:fontRef idx="minor">
+            <a:schemeClr val="lt1"/>
+          </a:fontRef>
+        </p:style>
+        <p:txBody>
+          <a:bodyPr rtlCol="0" anchor="ctr" wrap="square" lIns="45720" rIns="45720" tIns="0" bIns="0"/>
+          <a:lstStyle/>
+          <a:p>
+            <a:pPr algn="ctr"/>
+            <a:r>
+              <a:rPr sz="1000" b="1">
+                <a:solidFill>
+                  <a:srgbClr val="38BDF8"/>
+                </a:solidFill>
+                <a:latin typeface="Calibri"/>
+              </a:rPr>
+              <a:t>▸ Qwen2.5-7B-Instruct · vLLM on AMD GPU</a:t>
+            </a:r>
+          </a:p>
+        </p:txBody>
+      </p:sp>
+      <p:sp>
+        <p:nvSpPr>
+          <p:cNvPr id="25" name="TextBox 24"/>
+          <p:cNvSpPr txBox="1"/>
+          <p:nvPr/>
+        </p:nvSpPr>
+        <p:spPr>
+          <a:xfrm>
+            <a:off x="822960" y="6089904"/>
+            <a:ext cx="10515600" cy="457200"/>
+          </a:xfrm>
+          <a:prstGeom prst="rect">
+            <a:avLst/>
+          </a:prstGeom>
+          <a:noFill/>
+        </p:spPr>
+        <p:txBody>
+          <a:bodyPr wrap="square" anchor="ctr" lIns="0" rIns="0" tIns="0" bIns="0">
+            <a:spAutoFit/>
+          </a:bodyPr>
+          <a:lstStyle/>
+          <a:p>
+            <a:pPr algn="ctr"/>
+            <a:r>
+              <a:rPr sz="1250" b="1" i="0">
+                <a:solidFill>
+                  <a:srgbClr val="34D399"/>
+                </a:solidFill>
+                <a:latin typeface="Calibri"/>
+              </a:rPr>
+              <a:t>✓  </a:t>
+            </a:r>
+            <a:r>
+              <a:rPr sz="1250" b="0" i="0">
                 <a:solidFill>
                   <a:srgbClr val="94A3B8"/>
                 </a:solidFill>
                 <a:latin typeface="Calibri"/>
               </a:rPr>
-              <a:t>( live generated kit — added after the first real run )</a:t>
+              <a:t>Generated live on an AMD Developer Cloud GPU — no cloud LLM API, no mock data.</a:t>
             </a:r>
           </a:p>
         </p:txBody>
@@ -6859,7 +7745,7 @@
                 </a:solidFill>
                 <a:latin typeface="Calibri"/>
               </a:rPr>
-              <a:t>Fireworks AI on AMD GPUs</a:t>
+              <a:t>AMD Developer Cloud GPU · vLLM</a:t>
             </a:r>
           </a:p>
         </p:txBody>
@@ -7114,24 +8000,28 @@
           </a:bodyPr>
           <a:lstStyle/>
           <a:p>
-            <a:pPr algn="ctr"/>
-            <a:r>
-              <a:rPr sz="1600" b="0" i="0">
+            <a:pPr algn="ctr">
+              <a:lnSpc>
+                <a:spcPct val="105000"/>
+              </a:lnSpc>
+            </a:pPr>
+            <a:r>
+              <a:rPr sz="1550" b="0" i="0">
                 <a:solidFill>
                   <a:srgbClr val="94A3B8"/>
                 </a:solidFill>
                 <a:latin typeface="Calibri"/>
               </a:rPr>
-              <a:t>Fully containerized · publicly reproducible · </a:t>
-            </a:r>
-            <a:r>
-              <a:rPr sz="1600" b="1" i="0">
+              <a:t>Proven on an AMD Developer Cloud GPU (Qwen2.5-7B via vLLM) · </a:t>
+            </a:r>
+            <a:r>
+              <a:rPr sz="1550" b="1" i="0">
                 <a:solidFill>
                   <a:srgbClr val="F8FAFC"/>
                 </a:solidFill>
                 <a:latin typeface="Calibri"/>
               </a:rPr>
-              <a:t>runs the same locally and on AMD Developer Cloud.</a:t>
+              <a:t>same OpenAI-compatible code runs on Fireworks AI, also on AMD GPUs.</a:t>
             </a:r>
           </a:p>
         </p:txBody>
@@ -8281,7 +9171,7 @@
                 </a:solidFill>
                 <a:latin typeface="Calibri"/>
               </a:rPr>
-              <a:t>Fully containerized</a:t>
+              <a:t>Runs on AMD GPUs</a:t>
             </a:r>
           </a:p>
         </p:txBody>
@@ -8320,7 +9210,7 @@
                 </a:solidFill>
                 <a:latin typeface="Calibri"/>
               </a:rPr>
-              <a:t>Docker, ready for AMD Developer Cloud.</a:t>
+              <a:t>Self-hosted vLLM on AMD Developer Cloud.</a:t>
             </a:r>
           </a:p>
         </p:txBody>

</xml_diff>